<commit_message>
feat: integrate real construction video library, test video suite, and complete system testing protocol
</commit_message>
<xml_diff>
--- a/BaoCao_TienDo_AISafetyMonitor.pptx
+++ b/BaoCao_TienDo_AISafetyMonitor.pptx
@@ -4473,507 +4473,688 @@
         <p:nvPr/>
       </p:nvGrpSpPr>
       <p:grpSpPr/>
-      <p:sp>
-        <p:nvSpPr>
-          <p:cNvPr id="100063" name="TextBox 1"/>
+      <p:sp xmlns:a="http://schemas.openxmlformats.org/drawingml/2006/main">
+        <p:nvSpPr>
+          <p:cNvPr id="2" name="TextBox 1"/>
           <p:cNvSpPr txBox="1"/>
           <p:nvPr/>
         </p:nvSpPr>
         <p:spPr>
-          <a:xfrm xmlns:a="http://schemas.openxmlformats.org/drawingml/2006/main">
-            <a:off x="540000" y="324000"/>
-            <a:ext cx="11113200" cy="540000"/>
-          </a:xfrm>
-          <a:prstGeom xmlns:a="http://schemas.openxmlformats.org/drawingml/2006/main" prst="rect">
-            <a:avLst/>
-          </a:prstGeom>
-          <a:noFill xmlns:a="http://schemas.openxmlformats.org/drawingml/2006/main"/>
-          <a:ln xmlns:a="http://schemas.openxmlformats.org/drawingml/2006/main">
-            <a:noFill/>
-          </a:ln>
-        </p:spPr>
-        <p:txBody>
-          <a:bodyPr xmlns:a="http://schemas.openxmlformats.org/drawingml/2006/main"/>
-          <a:lstStyle xmlns:a="http://schemas.openxmlformats.org/drawingml/2006/main"/>
-          <a:p xmlns:a="http://schemas.openxmlformats.org/drawingml/2006/main">
-            <a:pPr algn="l"/>
-            <a:r>
-              <a:rPr lang="en-US" sz="3200" b="1">
+          <a:xfrm>
+            <a:off x="548640" y="365760"/>
+            <a:ext cx="11064240" cy="548640"/>
+          </a:xfrm>
+          <a:prstGeom prst="rect">
+            <a:avLst/>
+          </a:prstGeom>
+          <a:noFill/>
+        </p:spPr>
+        <p:txBody>
+          <a:bodyPr wrap="none">
+            <a:spAutoFit/>
+          </a:bodyPr>
+          <a:lstStyle/>
+          <a:p>
+            <a:pPr>
+              <a:defRPr sz="2800" b="1">
                 <a:solidFill>
                   <a:srgbClr val="0F172A"/>
                 </a:solidFill>
                 <a:latin typeface="Trebuchet MS"/>
-                <a:ea typeface="Trebuchet MS"/>
-              </a:rPr>
-              <a:t>5. Thiết kế Kiến trúc Cơ sở Dữ liệu</a:t>
-            </a:r>
-          </a:p>
-        </p:txBody>
-      </p:sp>
-      <p:sp>
-        <p:nvSpPr>
-          <p:cNvPr id="100064" name="TextBox 2"/>
+              </a:defRPr>
+            </a:pPr>
+            <a:r>
+              <a:t>5. Thiết kế Kiến trúc Cơ sở Dữ liệu &amp; Lưu trữ Lai</a:t>
+            </a:r>
+          </a:p>
+        </p:txBody>
+      </p:sp>
+      <p:sp xmlns:a="http://schemas.openxmlformats.org/drawingml/2006/main">
+        <p:nvSpPr>
+          <p:cNvPr id="3" name="TextBox 2"/>
           <p:cNvSpPr txBox="1"/>
           <p:nvPr/>
         </p:nvSpPr>
         <p:spPr>
-          <a:xfrm xmlns:a="http://schemas.openxmlformats.org/drawingml/2006/main">
-            <a:off x="540000" y="900000"/>
-            <a:ext cx="11113200" cy="324000"/>
-          </a:xfrm>
-          <a:prstGeom xmlns:a="http://schemas.openxmlformats.org/drawingml/2006/main" prst="rect">
-            <a:avLst/>
-          </a:prstGeom>
-          <a:noFill xmlns:a="http://schemas.openxmlformats.org/drawingml/2006/main"/>
-          <a:ln xmlns:a="http://schemas.openxmlformats.org/drawingml/2006/main">
-            <a:noFill/>
-          </a:ln>
-        </p:spPr>
-        <p:txBody>
-          <a:bodyPr xmlns:a="http://schemas.openxmlformats.org/drawingml/2006/main"/>
-          <a:lstStyle xmlns:a="http://schemas.openxmlformats.org/drawingml/2006/main"/>
-          <a:p xmlns:a="http://schemas.openxmlformats.org/drawingml/2006/main">
-            <a:pPr algn="l"/>
-            <a:r>
-              <a:rPr lang="en-US" sz="1600" b="0">
+          <a:xfrm>
+            <a:off x="548640" y="960120"/>
+            <a:ext cx="11064240" cy="365760"/>
+          </a:xfrm>
+          <a:prstGeom prst="rect">
+            <a:avLst/>
+          </a:prstGeom>
+          <a:noFill/>
+        </p:spPr>
+        <p:txBody>
+          <a:bodyPr wrap="none">
+            <a:spAutoFit/>
+          </a:bodyPr>
+          <a:lstStyle/>
+          <a:p>
+            <a:pPr>
+              <a:defRPr sz="1400">
                 <a:solidFill>
                   <a:srgbClr val="64748B"/>
                 </a:solidFill>
                 <a:latin typeface="Calibri"/>
-                <a:ea typeface="Calibri"/>
-              </a:rPr>
-              <a:t>Mô hình lưu trữ dữ liệu lai (Hybrid Storage) đảm bảo tính sẵn sàng và toàn vẹn dữ liệu</a:t>
-            </a:r>
-          </a:p>
-        </p:txBody>
-      </p:sp>
-      <p:sp>
-        <p:nvSpPr>
-          <p:cNvPr id="100065" name="TextBox 3"/>
-          <p:cNvSpPr/>
-          <p:nvPr/>
-        </p:nvSpPr>
-        <p:spPr>
-          <a:xfrm xmlns:a="http://schemas.openxmlformats.org/drawingml/2006/main">
-            <a:off x="540000" y="1296000"/>
-            <a:ext cx="4140000" cy="5112000"/>
-          </a:xfrm>
-          <a:prstGeom xmlns:a="http://schemas.openxmlformats.org/drawingml/2006/main" prst="roundRect">
-            <a:avLst/>
-          </a:prstGeom>
-          <a:solidFill xmlns:a="http://schemas.openxmlformats.org/drawingml/2006/main">
+              </a:defRPr>
+            </a:pPr>
+            <a:r>
+              <a:t>Mô hình lưu trữ dữ liệu lai (Hybrid Storage) và phân tầng 7 thực thể dữ liệu doanh nghiệp</a:t>
+            </a:r>
+          </a:p>
+        </p:txBody>
+      </p:sp>
+      <p:sp xmlns:a="http://schemas.openxmlformats.org/drawingml/2006/main">
+        <p:nvSpPr>
+          <p:cNvPr id="4" name="Rounded Rectangle 3"/>
+          <p:cNvSpPr/>
+          <p:nvPr/>
+        </p:nvSpPr>
+        <p:spPr>
+          <a:xfrm>
+            <a:off x="548640" y="1463040"/>
+            <a:ext cx="5394960" cy="4937760"/>
+          </a:xfrm>
+          <a:prstGeom prst="roundRect">
+            <a:avLst/>
+          </a:prstGeom>
+          <a:solidFill>
             <a:srgbClr val="FFFFFF"/>
           </a:solidFill>
-          <a:ln xmlns:a="http://schemas.openxmlformats.org/drawingml/2006/main" w="12700">
+          <a:ln w="12700">
             <a:solidFill>
               <a:srgbClr val="E2E8F0"/>
             </a:solidFill>
           </a:ln>
         </p:spPr>
-        <p:txBody>
-          <a:bodyPr xmlns:a="http://schemas.openxmlformats.org/drawingml/2006/main"/>
-          <a:lstStyle xmlns:a="http://schemas.openxmlformats.org/drawingml/2006/main"/>
-          <a:p xmlns:a="http://schemas.openxmlformats.org/drawingml/2006/main"/>
-        </p:txBody>
-      </p:sp>
-      <p:sp>
-        <p:nvSpPr>
-          <p:cNvPr id="100066" name="TextBox 4"/>
-          <p:cNvSpPr/>
-          <p:nvPr/>
-        </p:nvSpPr>
-        <p:spPr>
-          <a:xfrm xmlns:a="http://schemas.openxmlformats.org/drawingml/2006/main">
-            <a:off x="612000" y="1440000"/>
-            <a:ext cx="3996000" cy="432000"/>
-          </a:xfrm>
-          <a:prstGeom xmlns:a="http://schemas.openxmlformats.org/drawingml/2006/main" prst="roundRect">
-            <a:avLst/>
-          </a:prstGeom>
-          <a:solidFill xmlns:a="http://schemas.openxmlformats.org/drawingml/2006/main">
+        <p:style>
+          <a:lnRef idx="1">
+            <a:schemeClr val="accent1"/>
+          </a:lnRef>
+          <a:fillRef idx="3">
+            <a:schemeClr val="accent1"/>
+          </a:fillRef>
+          <a:effectRef idx="2">
+            <a:schemeClr val="accent1"/>
+          </a:effectRef>
+          <a:fontRef idx="minor">
+            <a:schemeClr val="lt1"/>
+          </a:fontRef>
+        </p:style>
+        <p:txBody>
+          <a:bodyPr rtlCol="0" anchor="ctr"/>
+          <a:lstStyle/>
+          <a:p>
+            <a:pPr algn="ctr"/>
+          </a:p>
+        </p:txBody>
+      </p:sp>
+      <p:sp xmlns:a="http://schemas.openxmlformats.org/drawingml/2006/main">
+        <p:nvSpPr>
+          <p:cNvPr id="5" name="Rounded Rectangle 4"/>
+          <p:cNvSpPr/>
+          <p:nvPr/>
+        </p:nvSpPr>
+        <p:spPr>
+          <a:xfrm>
+            <a:off x="640080" y="1600200"/>
+            <a:ext cx="5212080" cy="411480"/>
+          </a:xfrm>
+          <a:prstGeom prst="roundRect">
+            <a:avLst/>
+          </a:prstGeom>
+          <a:solidFill>
             <a:srgbClr val="0F172A"/>
           </a:solidFill>
-          <a:ln xmlns:a="http://schemas.openxmlformats.org/drawingml/2006/main">
-            <a:noFill/>
-          </a:ln>
-        </p:spPr>
-        <p:txBody>
-          <a:bodyPr xmlns:a="http://schemas.openxmlformats.org/drawingml/2006/main" anchor="ctr"/>
-          <a:lstStyle xmlns:a="http://schemas.openxmlformats.org/drawingml/2006/main"/>
-          <a:p xmlns:a="http://schemas.openxmlformats.org/drawingml/2006/main">
-            <a:pPr algn="ctr"/>
-            <a:r>
-              <a:rPr lang="en-US" sz="1500" b="1">
+          <a:ln>
+            <a:noFill/>
+          </a:ln>
+        </p:spPr>
+        <p:style>
+          <a:lnRef idx="1">
+            <a:schemeClr val="accent1"/>
+          </a:lnRef>
+          <a:fillRef idx="3">
+            <a:schemeClr val="accent1"/>
+          </a:fillRef>
+          <a:effectRef idx="2">
+            <a:schemeClr val="accent1"/>
+          </a:effectRef>
+          <a:fontRef idx="minor">
+            <a:schemeClr val="lt1"/>
+          </a:fontRef>
+        </p:style>
+        <p:txBody>
+          <a:bodyPr rtlCol="0" anchor="ctr"/>
+          <a:lstStyle/>
+          <a:p>
+            <a:pPr algn="ctr">
+              <a:defRPr sz="1300" b="1">
                 <a:solidFill>
                   <a:srgbClr val="FFFFFF"/>
                 </a:solidFill>
                 <a:latin typeface="Calibri"/>
-                <a:ea typeface="Calibri"/>
-              </a:rPr>
-              <a:t>GIẢI PHÁP LƯU TRỮ LAI (HYBRID)</a:t>
-            </a:r>
-          </a:p>
-        </p:txBody>
-      </p:sp>
-      <p:sp>
-        <p:nvSpPr>
-          <p:cNvPr id="100067" name="TextBox 5"/>
+              </a:defRPr>
+            </a:pPr>
+            <a:r>
+              <a:t>GIẢI PHÁP LƯU TRỮ LAI (HYBRID ARCHITECTURE)</a:t>
+            </a:r>
+          </a:p>
+        </p:txBody>
+      </p:sp>
+      <p:sp xmlns:a="http://schemas.openxmlformats.org/drawingml/2006/main">
+        <p:nvSpPr>
+          <p:cNvPr id="6" name="TextBox 5"/>
           <p:cNvSpPr txBox="1"/>
           <p:nvPr/>
         </p:nvSpPr>
         <p:spPr>
-          <a:xfrm xmlns:a="http://schemas.openxmlformats.org/drawingml/2006/main">
-            <a:off x="648000" y="2016000"/>
-            <a:ext cx="3924000" cy="4248000"/>
-          </a:xfrm>
-          <a:prstGeom xmlns:a="http://schemas.openxmlformats.org/drawingml/2006/main" prst="rect">
-            <a:avLst/>
-          </a:prstGeom>
-          <a:noFill xmlns:a="http://schemas.openxmlformats.org/drawingml/2006/main"/>
-          <a:ln xmlns:a="http://schemas.openxmlformats.org/drawingml/2006/main">
-            <a:noFill/>
-          </a:ln>
-        </p:spPr>
-        <p:txBody>
-          <a:bodyPr xmlns:a="http://schemas.openxmlformats.org/drawingml/2006/main"/>
-          <a:lstStyle xmlns:a="http://schemas.openxmlformats.org/drawingml/2006/main"/>
-          <a:p xmlns:a="http://schemas.openxmlformats.org/drawingml/2006/main">
-            <a:pPr algn="l"/>
-            <a:r>
-              <a:rPr lang="en-US" sz="1600" b="0">
-                <a:solidFill>
-                  <a:srgbClr val="334155"/>
-                </a:solidFill>
-                <a:latin typeface="Calibri"/>
-                <a:ea typeface="Calibri"/>
-              </a:rPr>
-              <a:t>1. CSDL PostgreSQL 15:</a:t>
-            </a:r>
-          </a:p>
-          <a:p xmlns:a="http://schemas.openxmlformats.org/drawingml/2006/main">
-            <a:pPr algn="l"/>
-            <a:r>
-              <a:rPr lang="en-US" sz="1600" b="0">
-                <a:solidFill>
-                  <a:srgbClr val="334155"/>
-                </a:solidFill>
-                <a:latin typeface="Calibri"/>
-                <a:ea typeface="Calibri"/>
-              </a:rPr>
-              <a:t>• Lưu trữ bền vững lịch sử vi phạm và cấu hình.</a:t>
-            </a:r>
-          </a:p>
-          <a:p xmlns:a="http://schemas.openxmlformats.org/drawingml/2006/main">
-            <a:pPr algn="l"/>
-            <a:r>
-              <a:rPr lang="en-US" sz="1600" b="0">
-                <a:solidFill>
-                  <a:srgbClr val="334155"/>
-                </a:solidFill>
-                <a:latin typeface="Calibri"/>
-                <a:ea typeface="Calibri"/>
-              </a:rPr>
-              <a:t>• Đảm bảo chuẩn ACID và tính toàn vẹn dữ liệu.</a:t>
-            </a:r>
-          </a:p>
-          <a:p xmlns:a="http://schemas.openxmlformats.org/drawingml/2006/main">
-            <a:pPr algn="l"/>
-            <a:r>
-              <a:rPr lang="en-US" sz="1600" b="0">
-                <a:solidFill>
-                  <a:srgbClr val="334155"/>
-                </a:solidFill>
-                <a:latin typeface="Calibri"/>
-                <a:ea typeface="Calibri"/>
-              </a:rPr>
-              <a:t/>
-            </a:r>
-          </a:p>
-          <a:p xmlns:a="http://schemas.openxmlformats.org/drawingml/2006/main">
-            <a:pPr algn="l"/>
-            <a:r>
-              <a:rPr lang="en-US" sz="1600" b="0">
-                <a:solidFill>
-                  <a:srgbClr val="334155"/>
-                </a:solidFill>
-                <a:latin typeface="Calibri"/>
-                <a:ea typeface="Calibri"/>
-              </a:rPr>
-              <a:t>2. In-memory Fallback:</a:t>
-            </a:r>
-          </a:p>
-          <a:p xmlns:a="http://schemas.openxmlformats.org/drawingml/2006/main">
-            <a:pPr algn="l"/>
-            <a:r>
-              <a:rPr lang="en-US" sz="1600" b="0">
-                <a:solidFill>
-                  <a:srgbClr val="334155"/>
-                </a:solidFill>
-                <a:latin typeface="Calibri"/>
-                <a:ea typeface="Calibri"/>
-              </a:rPr>
-              <a:t>• Tự động kích hoạt khi chạy độc lập / dev.</a:t>
-            </a:r>
-          </a:p>
-          <a:p xmlns:a="http://schemas.openxmlformats.org/drawingml/2006/main">
-            <a:pPr algn="l"/>
-            <a:r>
-              <a:rPr lang="en-US" sz="1600" b="0">
-                <a:solidFill>
-                  <a:srgbClr val="334155"/>
-                </a:solidFill>
-                <a:latin typeface="Calibri"/>
-                <a:ea typeface="Calibri"/>
-              </a:rPr>
-              <a:t>• Đảm bảo hệ thống hoạt động không gián đoạn.</a:t>
-            </a:r>
-          </a:p>
-          <a:p xmlns:a="http://schemas.openxmlformats.org/drawingml/2006/main">
-            <a:pPr algn="l"/>
-            <a:r>
-              <a:rPr lang="en-US" sz="1600" b="0">
-                <a:solidFill>
-                  <a:srgbClr val="334155"/>
-                </a:solidFill>
-                <a:latin typeface="Calibri"/>
-                <a:ea typeface="Calibri"/>
-              </a:rPr>
-              <a:t/>
-            </a:r>
-          </a:p>
-          <a:p xmlns:a="http://schemas.openxmlformats.org/drawingml/2006/main">
-            <a:pPr algn="l"/>
-            <a:r>
-              <a:rPr lang="en-US" sz="1600" b="0">
-                <a:solidFill>
-                  <a:srgbClr val="334155"/>
-                </a:solidFill>
-                <a:latin typeface="Calibri"/>
-                <a:ea typeface="Calibri"/>
-              </a:rPr>
-              <a:t>3. Snapshot File Volume:</a:t>
-            </a:r>
-          </a:p>
-          <a:p xmlns:a="http://schemas.openxmlformats.org/drawingml/2006/main">
-            <a:pPr algn="l"/>
-            <a:r>
-              <a:rPr lang="en-US" sz="1600" b="0">
-                <a:solidFill>
-                  <a:srgbClr val="334155"/>
-                </a:solidFill>
-                <a:latin typeface="Calibri"/>
-                <a:ea typeface="Calibri"/>
-              </a:rPr>
-              <a:t>• Lưu ảnh tại /data/violations/YYYY-MM-DD/.</a:t>
-            </a:r>
-          </a:p>
-          <a:p xmlns:a="http://schemas.openxmlformats.org/drawingml/2006/main">
-            <a:pPr algn="l"/>
-            <a:r>
-              <a:rPr lang="en-US" sz="1600" b="0">
-                <a:solidFill>
-                  <a:srgbClr val="334155"/>
-                </a:solidFill>
-                <a:latin typeface="Calibri"/>
-                <a:ea typeface="Calibri"/>
-              </a:rPr>
-              <a:t>• Tối ưu dung lượng CSDL và tải ảnh tức thì.</a:t>
-            </a:r>
-          </a:p>
-        </p:txBody>
-      </p:sp>
-      <p:sp>
-        <p:nvSpPr>
-          <p:cNvPr id="100068" name="TextBox 6"/>
-          <p:cNvSpPr/>
-          <p:nvPr/>
-        </p:nvSpPr>
-        <p:spPr>
-          <a:xfrm xmlns:a="http://schemas.openxmlformats.org/drawingml/2006/main">
-            <a:off x="4860000" y="1296000"/>
-            <a:ext cx="6793200" cy="5112000"/>
-          </a:xfrm>
-          <a:prstGeom xmlns:a="http://schemas.openxmlformats.org/drawingml/2006/main" prst="roundRect">
-            <a:avLst/>
-          </a:prstGeom>
-          <a:solidFill xmlns:a="http://schemas.openxmlformats.org/drawingml/2006/main">
+          <a:xfrm>
+            <a:off x="685800" y="2103120"/>
+            <a:ext cx="5120640" cy="4114800"/>
+          </a:xfrm>
+          <a:prstGeom prst="rect">
+            <a:avLst/>
+          </a:prstGeom>
+          <a:noFill/>
+        </p:spPr>
+        <p:txBody>
+          <a:bodyPr wrap="square">
+            <a:spAutoFit/>
+          </a:bodyPr>
+          <a:lstStyle/>
+          <a:p>
+            <a:pPr>
+              <a:spcAft>
+                <a:spcPts val="200"/>
+              </a:spcAft>
+              <a:defRPr sz="1150" b="1">
+                <a:solidFill>
+                  <a:srgbClr val="0284C7"/>
+                </a:solidFill>
+                <a:latin typeface="Calibri"/>
+              </a:defRPr>
+            </a:pPr>
+            <a:r>
+              <a:t>1. CSDL Quan hệ PostgreSQL 15 (Enterprise Core):</a:t>
+            </a:r>
+          </a:p>
+          <a:p>
+            <a:pPr>
+              <a:spcAft>
+                <a:spcPts val="200"/>
+              </a:spcAft>
+              <a:defRPr sz="1150" b="0">
+                <a:solidFill>
+                  <a:srgbClr val="334155"/>
+                </a:solidFill>
+                <a:latin typeface="Calibri"/>
+              </a:defRPr>
+            </a:pPr>
+            <a:r>
+              <a:t>• Chuẩn ACID: Bảo toàn dữ liệu giao dịch sự kiện vi phạm lâu dài.</a:t>
+            </a:r>
+          </a:p>
+          <a:p>
+            <a:pPr>
+              <a:spcAft>
+                <a:spcPts val="200"/>
+              </a:spcAft>
+              <a:defRPr sz="1150" b="0">
+                <a:solidFill>
+                  <a:srgbClr val="334155"/>
+                </a:solidFill>
+                <a:latin typeface="Calibri"/>
+              </a:defRPr>
+            </a:pPr>
+            <a:r>
+              <a:t>• Đánh chỉ mục B-Tree (Index) tối ưu truy vấn báo cáo đa kỳ &lt; 10ms.</a:t>
+            </a:r>
+          </a:p>
+          <a:p>
+            <a:pPr>
+              <a:spcAft>
+                <a:spcPts val="200"/>
+              </a:spcAft>
+              <a:defRPr sz="1150" b="0">
+                <a:solidFill>
+                  <a:srgbClr val="334155"/>
+                </a:solidFill>
+                <a:latin typeface="Calibri"/>
+              </a:defRPr>
+            </a:pPr>
+            <a:r>
+              <a:t>• Hỗ trợ kiểu JSONB lưu trữ linh hoạt chi tiết kiểm toán nhật ký.</a:t>
+            </a:r>
+          </a:p>
+          <a:p>
+            <a:pPr>
+              <a:spcAft>
+                <a:spcPts val="200"/>
+              </a:spcAft>
+              <a:defRPr sz="1150" b="0">
+                <a:solidFill>
+                  <a:srgbClr val="334155"/>
+                </a:solidFill>
+                <a:latin typeface="Calibri"/>
+              </a:defRPr>
+            </a:pPr>
+          </a:p>
+          <a:p>
+            <a:pPr>
+              <a:spcAft>
+                <a:spcPts val="200"/>
+              </a:spcAft>
+              <a:defRPr sz="1150" b="1">
+                <a:solidFill>
+                  <a:srgbClr val="0284C7"/>
+                </a:solidFill>
+                <a:latin typeface="Calibri"/>
+              </a:defRPr>
+            </a:pPr>
+            <a:r>
+              <a:t>2. Bộ nhớ đệm In-Memory Storage Fallback:</a:t>
+            </a:r>
+          </a:p>
+          <a:p>
+            <a:pPr>
+              <a:spcAft>
+                <a:spcPts val="200"/>
+              </a:spcAft>
+              <a:defRPr sz="1150" b="0">
+                <a:solidFill>
+                  <a:srgbClr val="334155"/>
+                </a:solidFill>
+                <a:latin typeface="Calibri"/>
+              </a:defRPr>
+            </a:pPr>
+            <a:r>
+              <a:t>• Tự động kích hoạt khi chạy chế độ Standalone Dev hoặc mất kết nối DB.</a:t>
+            </a:r>
+          </a:p>
+          <a:p>
+            <a:pPr>
+              <a:spcAft>
+                <a:spcPts val="200"/>
+              </a:spcAft>
+              <a:defRPr sz="1150" b="0">
+                <a:solidFill>
+                  <a:srgbClr val="334155"/>
+                </a:solidFill>
+                <a:latin typeface="Calibri"/>
+              </a:defRPr>
+            </a:pPr>
+            <a:r>
+              <a:t>• Đảm bảo luồng xử lý Video AI không bao giờ bị nghẽn gián đoạn.</a:t>
+            </a:r>
+          </a:p>
+          <a:p>
+            <a:pPr>
+              <a:spcAft>
+                <a:spcPts val="200"/>
+              </a:spcAft>
+              <a:defRPr sz="1150" b="0">
+                <a:solidFill>
+                  <a:srgbClr val="334155"/>
+                </a:solidFill>
+                <a:latin typeface="Calibri"/>
+              </a:defRPr>
+            </a:pPr>
+          </a:p>
+          <a:p>
+            <a:pPr>
+              <a:spcAft>
+                <a:spcPts val="200"/>
+              </a:spcAft>
+              <a:defRPr sz="1150" b="1">
+                <a:solidFill>
+                  <a:srgbClr val="0284C7"/>
+                </a:solidFill>
+                <a:latin typeface="Calibri"/>
+              </a:defRPr>
+            </a:pPr>
+            <a:r>
+              <a:t>3. Phân vùng Lưu trữ Tệp Bằng chứng (Snapshot Volume):</a:t>
+            </a:r>
+          </a:p>
+          <a:p>
+            <a:pPr>
+              <a:spcAft>
+                <a:spcPts val="200"/>
+              </a:spcAft>
+              <a:defRPr sz="1150" b="0">
+                <a:solidFill>
+                  <a:srgbClr val="334155"/>
+                </a:solidFill>
+                <a:latin typeface="Calibri"/>
+              </a:defRPr>
+            </a:pPr>
+            <a:r>
+              <a:t>• Tách biệt file ảnh JPEG ra khỏi CSDL: lưu tại /data/violations/YYYY-MM-DD/.</a:t>
+            </a:r>
+          </a:p>
+          <a:p>
+            <a:pPr>
+              <a:spcAft>
+                <a:spcPts val="200"/>
+              </a:spcAft>
+              <a:defRPr sz="1150" b="0">
+                <a:solidFill>
+                  <a:srgbClr val="334155"/>
+                </a:solidFill>
+                <a:latin typeface="Calibri"/>
+              </a:defRPr>
+            </a:pPr>
+            <a:r>
+              <a:t>• Giảm tải dung lượng database và tối ưu hóa I/O tải ảnh tức thì.</a:t>
+            </a:r>
+          </a:p>
+        </p:txBody>
+      </p:sp>
+      <p:sp xmlns:a="http://schemas.openxmlformats.org/drawingml/2006/main">
+        <p:nvSpPr>
+          <p:cNvPr id="7" name="Rounded Rectangle 6"/>
+          <p:cNvSpPr/>
+          <p:nvPr/>
+        </p:nvSpPr>
+        <p:spPr>
+          <a:xfrm>
+            <a:off x="6217920" y="1463040"/>
+            <a:ext cx="5394960" cy="4937760"/>
+          </a:xfrm>
+          <a:prstGeom prst="roundRect">
+            <a:avLst/>
+          </a:prstGeom>
+          <a:solidFill>
             <a:srgbClr val="FFFFFF"/>
           </a:solidFill>
-          <a:ln xmlns:a="http://schemas.openxmlformats.org/drawingml/2006/main" w="12700">
+          <a:ln w="12700">
             <a:solidFill>
               <a:srgbClr val="E2E8F0"/>
             </a:solidFill>
           </a:ln>
         </p:spPr>
-        <p:txBody>
-          <a:bodyPr xmlns:a="http://schemas.openxmlformats.org/drawingml/2006/main"/>
-          <a:lstStyle xmlns:a="http://schemas.openxmlformats.org/drawingml/2006/main"/>
-          <a:p xmlns:a="http://schemas.openxmlformats.org/drawingml/2006/main"/>
-        </p:txBody>
-      </p:sp>
-      <p:sp>
-        <p:nvSpPr>
-          <p:cNvPr id="100069" name="TextBox 7"/>
-          <p:cNvSpPr/>
-          <p:nvPr/>
-        </p:nvSpPr>
-        <p:spPr>
-          <a:xfrm xmlns:a="http://schemas.openxmlformats.org/drawingml/2006/main">
-            <a:off x="4932000" y="1440000"/>
-            <a:ext cx="6649200" cy="432000"/>
-          </a:xfrm>
-          <a:prstGeom xmlns:a="http://schemas.openxmlformats.org/drawingml/2006/main" prst="roundRect">
-            <a:avLst/>
-          </a:prstGeom>
-          <a:solidFill xmlns:a="http://schemas.openxmlformats.org/drawingml/2006/main">
+        <p:style>
+          <a:lnRef idx="1">
+            <a:schemeClr val="accent1"/>
+          </a:lnRef>
+          <a:fillRef idx="3">
+            <a:schemeClr val="accent1"/>
+          </a:fillRef>
+          <a:effectRef idx="2">
+            <a:schemeClr val="accent1"/>
+          </a:effectRef>
+          <a:fontRef idx="minor">
+            <a:schemeClr val="lt1"/>
+          </a:fontRef>
+        </p:style>
+        <p:txBody>
+          <a:bodyPr rtlCol="0" anchor="ctr"/>
+          <a:lstStyle/>
+          <a:p>
+            <a:pPr algn="ctr"/>
+          </a:p>
+        </p:txBody>
+      </p:sp>
+      <p:sp xmlns:a="http://schemas.openxmlformats.org/drawingml/2006/main">
+        <p:nvSpPr>
+          <p:cNvPr id="8" name="Rounded Rectangle 7"/>
+          <p:cNvSpPr/>
+          <p:nvPr/>
+        </p:nvSpPr>
+        <p:spPr>
+          <a:xfrm>
+            <a:off x="6309360" y="1600200"/>
+            <a:ext cx="5212080" cy="411480"/>
+          </a:xfrm>
+          <a:prstGeom prst="roundRect">
+            <a:avLst/>
+          </a:prstGeom>
+          <a:solidFill>
             <a:srgbClr val="0284C7"/>
           </a:solidFill>
-          <a:ln xmlns:a="http://schemas.openxmlformats.org/drawingml/2006/main">
-            <a:noFill/>
-          </a:ln>
-        </p:spPr>
-        <p:txBody>
-          <a:bodyPr xmlns:a="http://schemas.openxmlformats.org/drawingml/2006/main" anchor="ctr"/>
-          <a:lstStyle xmlns:a="http://schemas.openxmlformats.org/drawingml/2006/main"/>
-          <a:p xmlns:a="http://schemas.openxmlformats.org/drawingml/2006/main">
-            <a:pPr algn="ctr"/>
-            <a:r>
-              <a:rPr lang="en-US" sz="1500" b="1">
+          <a:ln>
+            <a:noFill/>
+          </a:ln>
+        </p:spPr>
+        <p:style>
+          <a:lnRef idx="1">
+            <a:schemeClr val="accent1"/>
+          </a:lnRef>
+          <a:fillRef idx="3">
+            <a:schemeClr val="accent1"/>
+          </a:fillRef>
+          <a:effectRef idx="2">
+            <a:schemeClr val="accent1"/>
+          </a:effectRef>
+          <a:fontRef idx="minor">
+            <a:schemeClr val="lt1"/>
+          </a:fontRef>
+        </p:style>
+        <p:txBody>
+          <a:bodyPr rtlCol="0" anchor="ctr"/>
+          <a:lstStyle/>
+          <a:p>
+            <a:pPr algn="ctr">
+              <a:defRPr sz="1300" b="1">
                 <a:solidFill>
                   <a:srgbClr val="FFFFFF"/>
                 </a:solidFill>
                 <a:latin typeface="Calibri"/>
-                <a:ea typeface="Calibri"/>
-              </a:rPr>
-              <a:t>VAI TRÒ CỦA CÁC THỰC THỂ DỮ LIỆU CHÍNH</a:t>
-            </a:r>
-          </a:p>
-        </p:txBody>
-      </p:sp>
-      <p:sp>
-        <p:nvSpPr>
-          <p:cNvPr id="100070" name="TextBox 8"/>
+              </a:defRPr>
+            </a:pPr>
+            <a:r>
+              <a:t>PHÂN TẦNG KIẾN TRÚC 7 BẢNG DỮ LIỆU</a:t>
+            </a:r>
+          </a:p>
+        </p:txBody>
+      </p:sp>
+      <p:sp xmlns:a="http://schemas.openxmlformats.org/drawingml/2006/main">
+        <p:nvSpPr>
+          <p:cNvPr id="9" name="TextBox 8"/>
           <p:cNvSpPr txBox="1"/>
           <p:nvPr/>
         </p:nvSpPr>
         <p:spPr>
-          <a:xfrm xmlns:a="http://schemas.openxmlformats.org/drawingml/2006/main">
-            <a:off x="5004000" y="2016000"/>
-            <a:ext cx="6505200" cy="4248000"/>
-          </a:xfrm>
-          <a:prstGeom xmlns:a="http://schemas.openxmlformats.org/drawingml/2006/main" prst="rect">
-            <a:avLst/>
-          </a:prstGeom>
-          <a:noFill xmlns:a="http://schemas.openxmlformats.org/drawingml/2006/main"/>
-          <a:ln xmlns:a="http://schemas.openxmlformats.org/drawingml/2006/main">
-            <a:noFill/>
-          </a:ln>
-        </p:spPr>
-        <p:txBody>
-          <a:bodyPr xmlns:a="http://schemas.openxmlformats.org/drawingml/2006/main"/>
-          <a:lstStyle xmlns:a="http://schemas.openxmlformats.org/drawingml/2006/main"/>
-          <a:p xmlns:a="http://schemas.openxmlformats.org/drawingml/2006/main">
-            <a:pPr algn="l"/>
-            <a:r>
-              <a:rPr lang="en-US" sz="1600" b="0">
-                <a:solidFill>
-                  <a:srgbClr val="334155"/>
-                </a:solidFill>
-                <a:latin typeface="Calibri"/>
-                <a:ea typeface="Calibri"/>
-              </a:rPr>
-              <a:t>• Bảng violations (Nhật ký vi phạm):</a:t>
-            </a:r>
-          </a:p>
-          <a:p xmlns:a="http://schemas.openxmlformats.org/drawingml/2006/main">
-            <a:pPr algn="l"/>
-            <a:r>
-              <a:rPr lang="en-US" sz="1600" b="0">
-                <a:solidFill>
-                  <a:srgbClr val="334155"/>
-                </a:solidFill>
-                <a:latin typeface="Calibri"/>
-                <a:ea typeface="Calibri"/>
-              </a:rPr>
-              <a:t>  Ghi nhận từng sự kiện vi phạm gồm mã sự kiện (ID), mốc thời gian, loại vi phạm PPE (không mũ, không áo...), độ tin cậy và đường dẫn ảnh snapshot bằng chứng.</a:t>
-            </a:r>
-          </a:p>
-          <a:p xmlns:a="http://schemas.openxmlformats.org/drawingml/2006/main">
-            <a:pPr algn="l"/>
-            <a:r>
-              <a:rPr lang="en-US" sz="1600" b="0">
-                <a:solidFill>
-                  <a:srgbClr val="334155"/>
-                </a:solidFill>
-                <a:latin typeface="Calibri"/>
-                <a:ea typeface="Calibri"/>
-              </a:rPr>
-              <a:t/>
-            </a:r>
-          </a:p>
-          <a:p xmlns:a="http://schemas.openxmlformats.org/drawingml/2006/main">
-            <a:pPr algn="l"/>
-            <a:r>
-              <a:rPr lang="en-US" sz="1600" b="0">
-                <a:solidFill>
-                  <a:srgbClr val="334155"/>
-                </a:solidFill>
-                <a:latin typeface="Calibri"/>
-                <a:ea typeface="Calibri"/>
-              </a:rPr>
-              <a:t>• Bảng notification_settings (Cấu hình cảnh báo):</a:t>
-            </a:r>
-          </a:p>
-          <a:p xmlns:a="http://schemas.openxmlformats.org/drawingml/2006/main">
-            <a:pPr algn="l"/>
-            <a:r>
-              <a:rPr lang="en-US" sz="1600" b="0">
-                <a:solidFill>
-                  <a:srgbClr val="334155"/>
-                </a:solidFill>
-                <a:latin typeface="Calibri"/>
-                <a:ea typeface="Calibri"/>
-              </a:rPr>
-              <a:t>  Lưu trữ trạng thái bật/tắt Telegram/Webhook, Bot Token, Chat ID nhận tin và khoảng thời gian chờ (cooldown) chụp ảnh snapshot.</a:t>
-            </a:r>
-          </a:p>
-          <a:p xmlns:a="http://schemas.openxmlformats.org/drawingml/2006/main">
-            <a:pPr algn="l"/>
-            <a:r>
-              <a:rPr lang="en-US" sz="1600" b="0">
-                <a:solidFill>
-                  <a:srgbClr val="334155"/>
-                </a:solidFill>
-                <a:latin typeface="Calibri"/>
-                <a:ea typeface="Calibri"/>
-              </a:rPr>
-              <a:t/>
-            </a:r>
-          </a:p>
-          <a:p xmlns:a="http://schemas.openxmlformats.org/drawingml/2006/main">
-            <a:pPr algn="l"/>
-            <a:r>
-              <a:rPr lang="en-US" sz="1600" b="0">
-                <a:solidFill>
-                  <a:srgbClr val="334155"/>
-                </a:solidFill>
-                <a:latin typeface="Calibri"/>
-                <a:ea typeface="Calibri"/>
-              </a:rPr>
-              <a:t>• Bảng ppe_rules_config (Quy định an toàn):</a:t>
-            </a:r>
-          </a:p>
-          <a:p xmlns:a="http://schemas.openxmlformats.org/drawingml/2006/main">
-            <a:pPr algn="l"/>
-            <a:r>
-              <a:rPr lang="en-US" sz="1600" b="0">
-                <a:solidFill>
-                  <a:srgbClr val="334155"/>
-                </a:solidFill>
-                <a:latin typeface="Calibri"/>
-                <a:ea typeface="Calibri"/>
-              </a:rPr>
-              <a:t>  Quản lý trạng thái áp dụng kiểm tra đối với từng trang bị bảo hộ cụ thể (mũ, áo, ủng, găng tay, kính) theo từng phân xưởng.</a:t>
+          <a:xfrm>
+            <a:off x="6355080" y="2103120"/>
+            <a:ext cx="5120640" cy="4114800"/>
+          </a:xfrm>
+          <a:prstGeom prst="rect">
+            <a:avLst/>
+          </a:prstGeom>
+          <a:noFill/>
+        </p:spPr>
+        <p:txBody>
+          <a:bodyPr wrap="square">
+            <a:spAutoFit/>
+          </a:bodyPr>
+          <a:lstStyle/>
+          <a:p>
+            <a:pPr>
+              <a:spcAft>
+                <a:spcPts val="200"/>
+              </a:spcAft>
+              <a:defRPr sz="1150" b="1">
+                <a:solidFill>
+                  <a:srgbClr val="1E3A8A"/>
+                </a:solidFill>
+                <a:latin typeface="Calibri"/>
+              </a:defRPr>
+            </a:pPr>
+            <a:r>
+              <a:t>Tầng 1: Quản trị &amp; Không gian (Master &amp; Spatial)</a:t>
+            </a:r>
+          </a:p>
+          <a:p>
+            <a:pPr>
+              <a:spcAft>
+                <a:spcPts val="200"/>
+              </a:spcAft>
+              <a:defRPr sz="1150" b="0">
+                <a:solidFill>
+                  <a:srgbClr val="334155"/>
+                </a:solidFill>
+                <a:latin typeface="Calibri"/>
+              </a:defRPr>
+            </a:pPr>
+            <a:r>
+              <a:t>• users: Tài khoản cán bộ an toàn, quản trị viên &amp; phân quyền RBAC.</a:t>
+            </a:r>
+          </a:p>
+          <a:p>
+            <a:pPr>
+              <a:spcAft>
+                <a:spcPts val="200"/>
+              </a:spcAft>
+              <a:defRPr sz="1150" b="0">
+                <a:solidFill>
+                  <a:srgbClr val="334155"/>
+                </a:solidFill>
+                <a:latin typeface="Calibri"/>
+              </a:defRPr>
+            </a:pPr>
+            <a:r>
+              <a:t>• locations: Khu vực, công trường &amp; phân xưởng giám sát.</a:t>
+            </a:r>
+          </a:p>
+          <a:p>
+            <a:pPr>
+              <a:spcAft>
+                <a:spcPts val="200"/>
+              </a:spcAft>
+              <a:defRPr sz="1150" b="0">
+                <a:solidFill>
+                  <a:srgbClr val="334155"/>
+                </a:solidFill>
+                <a:latin typeface="Calibri"/>
+              </a:defRPr>
+            </a:pPr>
+            <a:r>
+              <a:t>• cameras: Thiết bị camera IP, luồng RTSP &amp; thông số FPS/độ phân giải.</a:t>
+            </a:r>
+          </a:p>
+          <a:p>
+            <a:pPr>
+              <a:spcAft>
+                <a:spcPts val="200"/>
+              </a:spcAft>
+              <a:defRPr sz="1150" b="0">
+                <a:solidFill>
+                  <a:srgbClr val="334155"/>
+                </a:solidFill>
+                <a:latin typeface="Calibri"/>
+              </a:defRPr>
+            </a:pPr>
+          </a:p>
+          <a:p>
+            <a:pPr>
+              <a:spcAft>
+                <a:spcPts val="200"/>
+              </a:spcAft>
+              <a:defRPr sz="1150" b="1">
+                <a:solidFill>
+                  <a:srgbClr val="DC2626"/>
+                </a:solidFill>
+                <a:latin typeface="Calibri"/>
+              </a:defRPr>
+            </a:pPr>
+            <a:r>
+              <a:t>Tầng 2: Cốt lõi AI &amp; Sự kiện Vi phạm (Core Transactional)</a:t>
+            </a:r>
+          </a:p>
+          <a:p>
+            <a:pPr>
+              <a:spcAft>
+                <a:spcPts val="200"/>
+              </a:spcAft>
+              <a:defRPr sz="1150" b="0">
+                <a:solidFill>
+                  <a:srgbClr val="334155"/>
+                </a:solidFill>
+                <a:latin typeface="Calibri"/>
+              </a:defRPr>
+            </a:pPr>
+            <a:r>
+              <a:t>• ppe_rules_config: Cấu hình quy chuẩn trang bị an toàn theo từng khu vực.</a:t>
+            </a:r>
+          </a:p>
+          <a:p>
+            <a:pPr>
+              <a:spcAft>
+                <a:spcPts val="200"/>
+              </a:spcAft>
+              <a:defRPr sz="1150" b="0">
+                <a:solidFill>
+                  <a:srgbClr val="334155"/>
+                </a:solidFill>
+                <a:latin typeface="Calibri"/>
+              </a:defRPr>
+            </a:pPr>
+            <a:r>
+              <a:t>• violations: Nhật ký sự kiện vi phạm an toàn, track_id, độ tin cậy &amp; ảnh chụp bằng chứng snapshot.</a:t>
+            </a:r>
+          </a:p>
+          <a:p>
+            <a:pPr>
+              <a:spcAft>
+                <a:spcPts val="200"/>
+              </a:spcAft>
+              <a:defRPr sz="1150" b="0">
+                <a:solidFill>
+                  <a:srgbClr val="334155"/>
+                </a:solidFill>
+                <a:latin typeface="Calibri"/>
+              </a:defRPr>
+            </a:pPr>
+          </a:p>
+          <a:p>
+            <a:pPr>
+              <a:spcAft>
+                <a:spcPts val="200"/>
+              </a:spcAft>
+              <a:defRPr sz="1150" b="1">
+                <a:solidFill>
+                  <a:srgbClr val="7C3AED"/>
+                </a:solidFill>
+                <a:latin typeface="Calibri"/>
+              </a:defRPr>
+            </a:pPr>
+            <a:r>
+              <a:t>Tầng 3: Tích hợp Cảnh báo &amp; Kiểm toán (Integration &amp; Audit)</a:t>
+            </a:r>
+          </a:p>
+          <a:p>
+            <a:pPr>
+              <a:spcAft>
+                <a:spcPts val="200"/>
+              </a:spcAft>
+              <a:defRPr sz="1150" b="0">
+                <a:solidFill>
+                  <a:srgbClr val="334155"/>
+                </a:solidFill>
+                <a:latin typeface="Calibri"/>
+              </a:defRPr>
+            </a:pPr>
+            <a:r>
+              <a:t>• notification_settings: Cấu hình Telegram Bot, Webhook &amp; Cooldown.</a:t>
+            </a:r>
+          </a:p>
+          <a:p>
+            <a:pPr>
+              <a:spcAft>
+                <a:spcPts val="200"/>
+              </a:spcAft>
+              <a:defRPr sz="1150" b="0">
+                <a:solidFill>
+                  <a:srgbClr val="334155"/>
+                </a:solidFill>
+                <a:latin typeface="Calibri"/>
+              </a:defRPr>
+            </a:pPr>
+            <a:r>
+              <a:t>• audit_logs: Nhật ký kiểm toán thao tác hệ thống, xử lý sự cố &amp; xuất báo cáo.</a:t>
             </a:r>
           </a:p>
         </p:txBody>
@@ -4989,7 +5170,7 @@
     <p:bg>
       <p:bgPr>
         <a:solidFill xmlns:a="http://schemas.openxmlformats.org/drawingml/2006/main">
-          <a:srgbClr val="F8FAFC"/>
+          <a:srgbClr val="0F172A"/>
         </a:solidFill>
       </p:bgPr>
     </p:bg>
@@ -5000,668 +5181,102 @@
         <p:nvPr/>
       </p:nvGrpSpPr>
       <p:grpSpPr/>
-      <p:sp>
-        <p:nvSpPr>
-          <p:cNvPr id="100071" name="TextBox 1"/>
+      <p:sp xmlns:a="http://schemas.openxmlformats.org/drawingml/2006/main">
+        <p:nvSpPr>
+          <p:cNvPr id="2" name="TextBox 1"/>
           <p:cNvSpPr txBox="1"/>
           <p:nvPr/>
         </p:nvSpPr>
         <p:spPr>
-          <a:xfrm xmlns:a="http://schemas.openxmlformats.org/drawingml/2006/main">
-            <a:off x="540000" y="324000"/>
-            <a:ext cx="11113200" cy="540000"/>
-          </a:xfrm>
-          <a:prstGeom xmlns:a="http://schemas.openxmlformats.org/drawingml/2006/main" prst="rect">
-            <a:avLst/>
-          </a:prstGeom>
-          <a:noFill xmlns:a="http://schemas.openxmlformats.org/drawingml/2006/main"/>
-          <a:ln xmlns:a="http://schemas.openxmlformats.org/drawingml/2006/main">
-            <a:noFill/>
-          </a:ln>
-        </p:spPr>
-        <p:txBody>
-          <a:bodyPr xmlns:a="http://schemas.openxmlformats.org/drawingml/2006/main"/>
-          <a:lstStyle xmlns:a="http://schemas.openxmlformats.org/drawingml/2006/main"/>
-          <a:p xmlns:a="http://schemas.openxmlformats.org/drawingml/2006/main">
-            <a:pPr algn="l"/>
-            <a:r>
-              <a:rPr lang="en-US" sz="3200" b="1">
-                <a:solidFill>
-                  <a:srgbClr val="0F172A"/>
+          <a:xfrm>
+            <a:off x="548640" y="320040"/>
+            <a:ext cx="11064240" cy="502920"/>
+          </a:xfrm>
+          <a:prstGeom prst="rect">
+            <a:avLst/>
+          </a:prstGeom>
+          <a:noFill/>
+        </p:spPr>
+        <p:txBody>
+          <a:bodyPr wrap="none">
+            <a:spAutoFit/>
+          </a:bodyPr>
+          <a:lstStyle/>
+          <a:p>
+            <a:pPr>
+              <a:defRPr sz="2600" b="1">
+                <a:solidFill>
+                  <a:srgbClr val="FFFFFF"/>
                 </a:solidFill>
                 <a:latin typeface="Trebuchet MS"/>
-                <a:ea typeface="Trebuchet MS"/>
-              </a:rPr>
-              <a:t>6. Sơ đồ Thực thể Quan hệ (Database ERD)</a:t>
-            </a:r>
-          </a:p>
-        </p:txBody>
-      </p:sp>
-      <p:sp>
-        <p:nvSpPr>
-          <p:cNvPr id="100072" name="TextBox 2"/>
+              </a:defRPr>
+            </a:pPr>
+            <a:r>
+              <a:t>6. Sơ đồ Thực thể Quan hệ (Database ERD - 7 Bảng)</a:t>
+            </a:r>
+          </a:p>
+        </p:txBody>
+      </p:sp>
+      <p:sp xmlns:a="http://schemas.openxmlformats.org/drawingml/2006/main">
+        <p:nvSpPr>
+          <p:cNvPr id="3" name="TextBox 2"/>
           <p:cNvSpPr txBox="1"/>
           <p:nvPr/>
         </p:nvSpPr>
         <p:spPr>
-          <a:xfrm xmlns:a="http://schemas.openxmlformats.org/drawingml/2006/main">
-            <a:off x="540000" y="900000"/>
-            <a:ext cx="11113200" cy="324000"/>
-          </a:xfrm>
-          <a:prstGeom xmlns:a="http://schemas.openxmlformats.org/drawingml/2006/main" prst="rect">
-            <a:avLst/>
-          </a:prstGeom>
-          <a:noFill xmlns:a="http://schemas.openxmlformats.org/drawingml/2006/main"/>
-          <a:ln xmlns:a="http://schemas.openxmlformats.org/drawingml/2006/main">
-            <a:noFill/>
-          </a:ln>
-        </p:spPr>
-        <p:txBody>
-          <a:bodyPr xmlns:a="http://schemas.openxmlformats.org/drawingml/2006/main"/>
-          <a:lstStyle xmlns:a="http://schemas.openxmlformats.org/drawingml/2006/main"/>
-          <a:p xmlns:a="http://schemas.openxmlformats.org/drawingml/2006/main">
-            <a:pPr algn="l"/>
-            <a:r>
-              <a:rPr lang="en-US" sz="1600" b="0">
-                <a:solidFill>
-                  <a:srgbClr val="64748B"/>
-                </a:solidFill>
-                <a:latin typeface="Calibri"/>
-                <a:ea typeface="Calibri"/>
-              </a:rPr>
-              <a:t>Chi tiết các trường dữ liệu, khóa chính (PK), khóa ngoại (FK) và kiểu dữ liệu</a:t>
-            </a:r>
-          </a:p>
-        </p:txBody>
-      </p:sp>
-      <p:sp>
-        <p:nvSpPr>
-          <p:cNvPr id="100073" name="TextBox 3"/>
-          <p:cNvSpPr/>
-          <p:nvPr/>
-        </p:nvSpPr>
-        <p:spPr>
-          <a:xfrm xmlns:a="http://schemas.openxmlformats.org/drawingml/2006/main">
-            <a:off x="540000" y="1296000"/>
-            <a:ext cx="3456000" cy="5112000"/>
-          </a:xfrm>
-          <a:prstGeom xmlns:a="http://schemas.openxmlformats.org/drawingml/2006/main" prst="roundRect">
-            <a:avLst/>
-          </a:prstGeom>
-          <a:solidFill xmlns:a="http://schemas.openxmlformats.org/drawingml/2006/main">
-            <a:srgbClr val="FFFFFF"/>
-          </a:solidFill>
-          <a:ln xmlns:a="http://schemas.openxmlformats.org/drawingml/2006/main" w="12700">
-            <a:solidFill>
-              <a:srgbClr val="E2E8F0"/>
-            </a:solidFill>
-          </a:ln>
-        </p:spPr>
-        <p:txBody>
-          <a:bodyPr xmlns:a="http://schemas.openxmlformats.org/drawingml/2006/main"/>
-          <a:lstStyle xmlns:a="http://schemas.openxmlformats.org/drawingml/2006/main"/>
-          <a:p xmlns:a="http://schemas.openxmlformats.org/drawingml/2006/main"/>
-        </p:txBody>
-      </p:sp>
-      <p:sp>
-        <p:nvSpPr>
-          <p:cNvPr id="100074" name="TextBox 4"/>
-          <p:cNvSpPr/>
-          <p:nvPr/>
-        </p:nvSpPr>
-        <p:spPr>
-          <a:xfrm xmlns:a="http://schemas.openxmlformats.org/drawingml/2006/main">
-            <a:off x="612000" y="1440000"/>
-            <a:ext cx="3312000" cy="432000"/>
-          </a:xfrm>
-          <a:prstGeom xmlns:a="http://schemas.openxmlformats.org/drawingml/2006/main" prst="roundRect">
-            <a:avLst/>
-          </a:prstGeom>
-          <a:solidFill xmlns:a="http://schemas.openxmlformats.org/drawingml/2006/main">
-            <a:srgbClr val="0F172A"/>
-          </a:solidFill>
-          <a:ln xmlns:a="http://schemas.openxmlformats.org/drawingml/2006/main">
-            <a:noFill/>
-          </a:ln>
-        </p:spPr>
-        <p:txBody>
-          <a:bodyPr xmlns:a="http://schemas.openxmlformats.org/drawingml/2006/main" anchor="ctr"/>
-          <a:lstStyle xmlns:a="http://schemas.openxmlformats.org/drawingml/2006/main"/>
-          <a:p xmlns:a="http://schemas.openxmlformats.org/drawingml/2006/main">
-            <a:pPr algn="ctr"/>
-            <a:r>
-              <a:rPr lang="en-US" sz="1500" b="1">
-                <a:solidFill>
-                  <a:srgbClr val="FFFFFF"/>
-                </a:solidFill>
-                <a:latin typeface="Calibri"/>
-                <a:ea typeface="Calibri"/>
-              </a:rPr>
-              <a:t>TABLE: violations</a:t>
-            </a:r>
-          </a:p>
-        </p:txBody>
-      </p:sp>
-      <p:sp>
-        <p:nvSpPr>
-          <p:cNvPr id="100075" name="TextBox 5"/>
-          <p:cNvSpPr txBox="1"/>
-          <p:nvPr/>
-        </p:nvSpPr>
-        <p:spPr>
-          <a:xfrm xmlns:a="http://schemas.openxmlformats.org/drawingml/2006/main">
-            <a:off x="648000" y="2016000"/>
-            <a:ext cx="3240000" cy="4176000"/>
-          </a:xfrm>
-          <a:prstGeom xmlns:a="http://schemas.openxmlformats.org/drawingml/2006/main" prst="rect">
-            <a:avLst/>
-          </a:prstGeom>
-          <a:noFill xmlns:a="http://schemas.openxmlformats.org/drawingml/2006/main"/>
-          <a:ln xmlns:a="http://schemas.openxmlformats.org/drawingml/2006/main">
-            <a:noFill/>
-          </a:ln>
-        </p:spPr>
-        <p:txBody>
-          <a:bodyPr xmlns:a="http://schemas.openxmlformats.org/drawingml/2006/main"/>
-          <a:lstStyle xmlns:a="http://schemas.openxmlformats.org/drawingml/2006/main"/>
-          <a:p xmlns:a="http://schemas.openxmlformats.org/drawingml/2006/main">
-            <a:pPr algn="l"/>
-            <a:r>
-              <a:rPr lang="en-US" sz="1500" b="0">
-                <a:solidFill>
-                  <a:srgbClr val="0F172A"/>
-                </a:solidFill>
-                <a:latin typeface="Consolas"/>
-                <a:ea typeface="Consolas"/>
-              </a:rPr>
-              <a:t>• [PK] id: VARCHAR(50)</a:t>
-            </a:r>
-          </a:p>
-          <a:p xmlns:a="http://schemas.openxmlformats.org/drawingml/2006/main">
-            <a:pPr algn="l"/>
-            <a:r>
-              <a:rPr lang="en-US" sz="1500" b="0">
-                <a:solidFill>
-                  <a:srgbClr val="0F172A"/>
-                </a:solidFill>
-                <a:latin typeface="Consolas"/>
-                <a:ea typeface="Consolas"/>
-              </a:rPr>
-              <a:t>• timestamp: TIMESTAMPTZ</a:t>
-            </a:r>
-          </a:p>
-          <a:p xmlns:a="http://schemas.openxmlformats.org/drawingml/2006/main">
-            <a:pPr algn="l"/>
-            <a:r>
-              <a:rPr lang="en-US" sz="1500" b="0">
-                <a:solidFill>
-                  <a:srgbClr val="0F172A"/>
-                </a:solidFill>
-                <a:latin typeface="Consolas"/>
-                <a:ea typeface="Consolas"/>
-              </a:rPr>
-              <a:t>• type: VARCHAR(50)</a:t>
-            </a:r>
-          </a:p>
-          <a:p xmlns:a="http://schemas.openxmlformats.org/drawingml/2006/main">
-            <a:pPr algn="l"/>
-            <a:r>
-              <a:rPr lang="en-US" sz="1500" b="0">
-                <a:solidFill>
-                  <a:srgbClr val="0F172A"/>
-                </a:solidFill>
-                <a:latin typeface="Consolas"/>
-                <a:ea typeface="Consolas"/>
-              </a:rPr>
-              <a:t>• confidence: REAL</a:t>
-            </a:r>
-          </a:p>
-          <a:p xmlns:a="http://schemas.openxmlformats.org/drawingml/2006/main">
-            <a:pPr algn="l"/>
-            <a:r>
-              <a:rPr lang="en-US" sz="1500" b="0">
-                <a:solidFill>
-                  <a:srgbClr val="0F172A"/>
-                </a:solidFill>
-                <a:latin typeface="Consolas"/>
-                <a:ea typeface="Consolas"/>
-              </a:rPr>
-              <a:t>• snapshot_url: VARCHAR</a:t>
-            </a:r>
-          </a:p>
-          <a:p xmlns:a="http://schemas.openxmlformats.org/drawingml/2006/main">
-            <a:pPr algn="l"/>
-            <a:r>
-              <a:rPr lang="en-US" sz="1500" b="0">
-                <a:solidFill>
-                  <a:srgbClr val="0F172A"/>
-                </a:solidFill>
-                <a:latin typeface="Consolas"/>
-                <a:ea typeface="Consolas"/>
-              </a:rPr>
-              <a:t>• track_id: INTEGER</a:t>
-            </a:r>
-          </a:p>
-          <a:p xmlns:a="http://schemas.openxmlformats.org/drawingml/2006/main">
-            <a:pPr algn="l"/>
-            <a:r>
-              <a:rPr lang="en-US" sz="1500" b="0">
-                <a:solidFill>
-                  <a:srgbClr val="0F172A"/>
-                </a:solidFill>
-                <a:latin typeface="Consolas"/>
-                <a:ea typeface="Consolas"/>
-              </a:rPr>
-              <a:t>• camera_id: VARCHAR(50)</a:t>
-            </a:r>
-          </a:p>
-          <a:p xmlns:a="http://schemas.openxmlformats.org/drawingml/2006/main">
-            <a:pPr algn="l"/>
-            <a:r>
-              <a:rPr lang="en-US" sz="1500" b="0">
-                <a:solidFill>
-                  <a:srgbClr val="0F172A"/>
-                </a:solidFill>
-                <a:latin typeface="Consolas"/>
-                <a:ea typeface="Consolas"/>
-              </a:rPr>
-              <a:t>• status: VARCHAR(20)</a:t>
-            </a:r>
-          </a:p>
-        </p:txBody>
-      </p:sp>
-      <p:sp>
-        <p:nvSpPr>
-          <p:cNvPr id="100076" name="TextBox 6"/>
-          <p:cNvSpPr/>
-          <p:nvPr/>
-        </p:nvSpPr>
-        <p:spPr>
-          <a:xfrm xmlns:a="http://schemas.openxmlformats.org/drawingml/2006/main">
-            <a:off x="4356000" y="1296000"/>
-            <a:ext cx="3456000" cy="5112000"/>
-          </a:xfrm>
-          <a:prstGeom xmlns:a="http://schemas.openxmlformats.org/drawingml/2006/main" prst="roundRect">
-            <a:avLst/>
-          </a:prstGeom>
-          <a:solidFill xmlns:a="http://schemas.openxmlformats.org/drawingml/2006/main">
-            <a:srgbClr val="FFFFFF"/>
-          </a:solidFill>
-          <a:ln xmlns:a="http://schemas.openxmlformats.org/drawingml/2006/main" w="12700">
-            <a:solidFill>
-              <a:srgbClr val="E2E8F0"/>
-            </a:solidFill>
-          </a:ln>
-        </p:spPr>
-        <p:txBody>
-          <a:bodyPr xmlns:a="http://schemas.openxmlformats.org/drawingml/2006/main"/>
-          <a:lstStyle xmlns:a="http://schemas.openxmlformats.org/drawingml/2006/main"/>
-          <a:p xmlns:a="http://schemas.openxmlformats.org/drawingml/2006/main"/>
-        </p:txBody>
-      </p:sp>
-      <p:sp>
-        <p:nvSpPr>
-          <p:cNvPr id="100077" name="TextBox 7"/>
-          <p:cNvSpPr/>
-          <p:nvPr/>
-        </p:nvSpPr>
-        <p:spPr>
-          <a:xfrm xmlns:a="http://schemas.openxmlformats.org/drawingml/2006/main">
-            <a:off x="4428000" y="1440000"/>
-            <a:ext cx="3312000" cy="432000"/>
-          </a:xfrm>
-          <a:prstGeom xmlns:a="http://schemas.openxmlformats.org/drawingml/2006/main" prst="roundRect">
-            <a:avLst/>
-          </a:prstGeom>
-          <a:solidFill xmlns:a="http://schemas.openxmlformats.org/drawingml/2006/main">
-            <a:srgbClr val="0284C7"/>
-          </a:solidFill>
-          <a:ln xmlns:a="http://schemas.openxmlformats.org/drawingml/2006/main">
-            <a:noFill/>
-          </a:ln>
-        </p:spPr>
-        <p:txBody>
-          <a:bodyPr xmlns:a="http://schemas.openxmlformats.org/drawingml/2006/main" anchor="ctr"/>
-          <a:lstStyle xmlns:a="http://schemas.openxmlformats.org/drawingml/2006/main"/>
-          <a:p xmlns:a="http://schemas.openxmlformats.org/drawingml/2006/main">
-            <a:pPr algn="ctr"/>
-            <a:r>
-              <a:rPr lang="en-US" sz="1500" b="1">
-                <a:solidFill>
-                  <a:srgbClr val="FFFFFF"/>
-                </a:solidFill>
-                <a:latin typeface="Calibri"/>
-                <a:ea typeface="Calibri"/>
-              </a:rPr>
-              <a:t>TABLE: notification_settings</a:t>
-            </a:r>
-          </a:p>
-        </p:txBody>
-      </p:sp>
-      <p:sp>
-        <p:nvSpPr>
-          <p:cNvPr id="100078" name="TextBox 8"/>
-          <p:cNvSpPr txBox="1"/>
-          <p:nvPr/>
-        </p:nvSpPr>
-        <p:spPr>
-          <a:xfrm xmlns:a="http://schemas.openxmlformats.org/drawingml/2006/main">
-            <a:off x="4464000" y="2016000"/>
-            <a:ext cx="3240000" cy="4176000"/>
-          </a:xfrm>
-          <a:prstGeom xmlns:a="http://schemas.openxmlformats.org/drawingml/2006/main" prst="rect">
-            <a:avLst/>
-          </a:prstGeom>
-          <a:noFill xmlns:a="http://schemas.openxmlformats.org/drawingml/2006/main"/>
-          <a:ln xmlns:a="http://schemas.openxmlformats.org/drawingml/2006/main">
-            <a:noFill/>
-          </a:ln>
-        </p:spPr>
-        <p:txBody>
-          <a:bodyPr xmlns:a="http://schemas.openxmlformats.org/drawingml/2006/main"/>
-          <a:lstStyle xmlns:a="http://schemas.openxmlformats.org/drawingml/2006/main"/>
-          <a:p xmlns:a="http://schemas.openxmlformats.org/drawingml/2006/main">
-            <a:pPr algn="l"/>
-            <a:r>
-              <a:rPr lang="en-US" sz="1500" b="0">
-                <a:solidFill>
-                  <a:srgbClr val="0F172A"/>
-                </a:solidFill>
-                <a:latin typeface="Consolas"/>
-                <a:ea typeface="Consolas"/>
-              </a:rPr>
-              <a:t>• [PK] id: INTEGER</a:t>
-            </a:r>
-          </a:p>
-          <a:p xmlns:a="http://schemas.openxmlformats.org/drawingml/2006/main">
-            <a:pPr algn="l"/>
-            <a:r>
-              <a:rPr lang="en-US" sz="1500" b="0">
-                <a:solidFill>
-                  <a:srgbClr val="0F172A"/>
-                </a:solidFill>
-                <a:latin typeface="Consolas"/>
-                <a:ea typeface="Consolas"/>
-              </a:rPr>
-              <a:t>• telegram_enabled: BOOL</a:t>
-            </a:r>
-          </a:p>
-          <a:p xmlns:a="http://schemas.openxmlformats.org/drawingml/2006/main">
-            <a:pPr algn="l"/>
-            <a:r>
-              <a:rPr lang="en-US" sz="1500" b="0">
-                <a:solidFill>
-                  <a:srgbClr val="0F172A"/>
-                </a:solidFill>
-                <a:latin typeface="Consolas"/>
-                <a:ea typeface="Consolas"/>
-              </a:rPr>
-              <a:t>• telegram_bot_token: TEXT</a:t>
-            </a:r>
-          </a:p>
-          <a:p xmlns:a="http://schemas.openxmlformats.org/drawingml/2006/main">
-            <a:pPr algn="l"/>
-            <a:r>
-              <a:rPr lang="en-US" sz="1500" b="0">
-                <a:solidFill>
-                  <a:srgbClr val="0F172A"/>
-                </a:solidFill>
-                <a:latin typeface="Consolas"/>
-                <a:ea typeface="Consolas"/>
-              </a:rPr>
-              <a:t>• telegram_chat_id: TEXT</a:t>
-            </a:r>
-          </a:p>
-          <a:p xmlns:a="http://schemas.openxmlformats.org/drawingml/2006/main">
-            <a:pPr algn="l"/>
-            <a:r>
-              <a:rPr lang="en-US" sz="1500" b="0">
-                <a:solidFill>
-                  <a:srgbClr val="0F172A"/>
-                </a:solidFill>
-                <a:latin typeface="Consolas"/>
-                <a:ea typeface="Consolas"/>
-              </a:rPr>
-              <a:t>• webhook_enabled: BOOL</a:t>
-            </a:r>
-          </a:p>
-          <a:p xmlns:a="http://schemas.openxmlformats.org/drawingml/2006/main">
-            <a:pPr algn="l"/>
-            <a:r>
-              <a:rPr lang="en-US" sz="1500" b="0">
-                <a:solidFill>
-                  <a:srgbClr val="0F172A"/>
-                </a:solidFill>
-                <a:latin typeface="Consolas"/>
-                <a:ea typeface="Consolas"/>
-              </a:rPr>
-              <a:t>• webhook_url: VARCHAR</a:t>
-            </a:r>
-          </a:p>
-          <a:p xmlns:a="http://schemas.openxmlformats.org/drawingml/2006/main">
-            <a:pPr algn="l"/>
-            <a:r>
-              <a:rPr lang="en-US" sz="1500" b="0">
-                <a:solidFill>
-                  <a:srgbClr val="0F172A"/>
-                </a:solidFill>
-                <a:latin typeface="Consolas"/>
-                <a:ea typeface="Consolas"/>
-              </a:rPr>
-              <a:t>• snapshot_cooldown: INT</a:t>
-            </a:r>
-          </a:p>
-          <a:p xmlns:a="http://schemas.openxmlformats.org/drawingml/2006/main">
-            <a:pPr algn="l"/>
-            <a:r>
-              <a:rPr lang="en-US" sz="1500" b="0">
-                <a:solidFill>
-                  <a:srgbClr val="0F172A"/>
-                </a:solidFill>
-                <a:latin typeface="Consolas"/>
-                <a:ea typeface="Consolas"/>
-              </a:rPr>
-              <a:t>• updated_at: TIMESTAMPTZ</a:t>
-            </a:r>
-          </a:p>
-        </p:txBody>
-      </p:sp>
-      <p:sp>
-        <p:nvSpPr>
-          <p:cNvPr id="100079" name="TextBox 9"/>
-          <p:cNvSpPr/>
-          <p:nvPr/>
-        </p:nvSpPr>
-        <p:spPr>
-          <a:xfrm xmlns:a="http://schemas.openxmlformats.org/drawingml/2006/main">
-            <a:off x="8172000" y="1296000"/>
-            <a:ext cx="3456000" cy="5112000"/>
-          </a:xfrm>
-          <a:prstGeom xmlns:a="http://schemas.openxmlformats.org/drawingml/2006/main" prst="roundRect">
-            <a:avLst/>
-          </a:prstGeom>
-          <a:solidFill xmlns:a="http://schemas.openxmlformats.org/drawingml/2006/main">
-            <a:srgbClr val="FFFFFF"/>
-          </a:solidFill>
-          <a:ln xmlns:a="http://schemas.openxmlformats.org/drawingml/2006/main" w="12700">
-            <a:solidFill>
-              <a:srgbClr val="E2E8F0"/>
-            </a:solidFill>
-          </a:ln>
-        </p:spPr>
-        <p:txBody>
-          <a:bodyPr xmlns:a="http://schemas.openxmlformats.org/drawingml/2006/main"/>
-          <a:lstStyle xmlns:a="http://schemas.openxmlformats.org/drawingml/2006/main"/>
-          <a:p xmlns:a="http://schemas.openxmlformats.org/drawingml/2006/main"/>
-        </p:txBody>
-      </p:sp>
-      <p:sp>
-        <p:nvSpPr>
-          <p:cNvPr id="100080" name="TextBox 10"/>
-          <p:cNvSpPr/>
-          <p:nvPr/>
-        </p:nvSpPr>
-        <p:spPr>
-          <a:xfrm xmlns:a="http://schemas.openxmlformats.org/drawingml/2006/main">
-            <a:off x="8244000" y="1440000"/>
-            <a:ext cx="3312000" cy="432000"/>
-          </a:xfrm>
-          <a:prstGeom xmlns:a="http://schemas.openxmlformats.org/drawingml/2006/main" prst="roundRect">
-            <a:avLst/>
-          </a:prstGeom>
-          <a:solidFill xmlns:a="http://schemas.openxmlformats.org/drawingml/2006/main">
-            <a:srgbClr val="059669"/>
-          </a:solidFill>
-          <a:ln xmlns:a="http://schemas.openxmlformats.org/drawingml/2006/main">
-            <a:noFill/>
-          </a:ln>
-        </p:spPr>
-        <p:txBody>
-          <a:bodyPr xmlns:a="http://schemas.openxmlformats.org/drawingml/2006/main" anchor="ctr"/>
-          <a:lstStyle xmlns:a="http://schemas.openxmlformats.org/drawingml/2006/main"/>
-          <a:p xmlns:a="http://schemas.openxmlformats.org/drawingml/2006/main">
-            <a:pPr algn="ctr"/>
-            <a:r>
-              <a:rPr lang="en-US" sz="1500" b="1">
-                <a:solidFill>
-                  <a:srgbClr val="FFFFFF"/>
-                </a:solidFill>
-                <a:latin typeface="Calibri"/>
-                <a:ea typeface="Calibri"/>
-              </a:rPr>
-              <a:t>TABLE: ppe_rules_config</a:t>
-            </a:r>
-          </a:p>
-        </p:txBody>
-      </p:sp>
-      <p:sp>
-        <p:nvSpPr>
-          <p:cNvPr id="100081" name="TextBox 11"/>
-          <p:cNvSpPr txBox="1"/>
-          <p:nvPr/>
-        </p:nvSpPr>
-        <p:spPr>
-          <a:xfrm xmlns:a="http://schemas.openxmlformats.org/drawingml/2006/main">
-            <a:off x="8280000" y="2016000"/>
-            <a:ext cx="3240000" cy="4176000"/>
-          </a:xfrm>
-          <a:prstGeom xmlns:a="http://schemas.openxmlformats.org/drawingml/2006/main" prst="rect">
-            <a:avLst/>
-          </a:prstGeom>
-          <a:noFill xmlns:a="http://schemas.openxmlformats.org/drawingml/2006/main"/>
-          <a:ln xmlns:a="http://schemas.openxmlformats.org/drawingml/2006/main">
-            <a:noFill/>
-          </a:ln>
-        </p:spPr>
-        <p:txBody>
-          <a:bodyPr xmlns:a="http://schemas.openxmlformats.org/drawingml/2006/main"/>
-          <a:lstStyle xmlns:a="http://schemas.openxmlformats.org/drawingml/2006/main"/>
-          <a:p xmlns:a="http://schemas.openxmlformats.org/drawingml/2006/main">
-            <a:pPr algn="l"/>
-            <a:r>
-              <a:rPr lang="en-US" sz="1500" b="0">
-                <a:solidFill>
-                  <a:srgbClr val="0F172A"/>
-                </a:solidFill>
-                <a:latin typeface="Consolas"/>
-                <a:ea typeface="Consolas"/>
-              </a:rPr>
-              <a:t>• [PK] rule_id: VARCHAR(50)</a:t>
-            </a:r>
-          </a:p>
-          <a:p xmlns:a="http://schemas.openxmlformats.org/drawingml/2006/main">
-            <a:pPr algn="l"/>
-            <a:r>
-              <a:rPr lang="en-US" sz="1500" b="0">
-                <a:solidFill>
-                  <a:srgbClr val="0F172A"/>
-                </a:solidFill>
-                <a:latin typeface="Consolas"/>
-                <a:ea typeface="Consolas"/>
-              </a:rPr>
-              <a:t>• rule_name: VARCHAR(100)</a:t>
-            </a:r>
-          </a:p>
-          <a:p xmlns:a="http://schemas.openxmlformats.org/drawingml/2006/main">
-            <a:pPr algn="l"/>
-            <a:r>
-              <a:rPr lang="en-US" sz="1500" b="0">
-                <a:solidFill>
-                  <a:srgbClr val="0F172A"/>
-                </a:solidFill>
-                <a:latin typeface="Consolas"/>
-                <a:ea typeface="Consolas"/>
-              </a:rPr>
-              <a:t>• target_class: VARCHAR(50)</a:t>
-            </a:r>
-          </a:p>
-          <a:p xmlns:a="http://schemas.openxmlformats.org/drawingml/2006/main">
-            <a:pPr algn="l"/>
-            <a:r>
-              <a:rPr lang="en-US" sz="1500" b="0">
-                <a:solidFill>
-                  <a:srgbClr val="0F172A"/>
-                </a:solidFill>
-                <a:latin typeface="Consolas"/>
-                <a:ea typeface="Consolas"/>
-              </a:rPr>
-              <a:t>• is_active: BOOLEAN</a:t>
-            </a:r>
-          </a:p>
-          <a:p xmlns:a="http://schemas.openxmlformats.org/drawingml/2006/main">
-            <a:pPr algn="l"/>
-            <a:r>
-              <a:rPr lang="en-US" sz="1500" b="0">
-                <a:solidFill>
-                  <a:srgbClr val="0F172A"/>
-                </a:solidFill>
-                <a:latin typeface="Consolas"/>
-                <a:ea typeface="Consolas"/>
-              </a:rPr>
-              <a:t>• severity: VARCHAR(20)</a:t>
-            </a:r>
-          </a:p>
-          <a:p xmlns:a="http://schemas.openxmlformats.org/drawingml/2006/main">
-            <a:pPr algn="l"/>
-            <a:r>
-              <a:rPr lang="en-US" sz="1500" b="0">
-                <a:solidFill>
-                  <a:srgbClr val="0F172A"/>
-                </a:solidFill>
-                <a:latin typeface="Consolas"/>
-                <a:ea typeface="Consolas"/>
-              </a:rPr>
-              <a:t>• description: TEXT</a:t>
-            </a:r>
-          </a:p>
-          <a:p xmlns:a="http://schemas.openxmlformats.org/drawingml/2006/main">
-            <a:pPr algn="l"/>
-            <a:r>
-              <a:rPr lang="en-US" sz="1500" b="0">
-                <a:solidFill>
-                  <a:srgbClr val="0F172A"/>
-                </a:solidFill>
-                <a:latin typeface="Consolas"/>
-                <a:ea typeface="Consolas"/>
-              </a:rPr>
-              <a:t>• created_at: TIMESTAMPTZ</a:t>
-            </a:r>
-          </a:p>
-          <a:p xmlns:a="http://schemas.openxmlformats.org/drawingml/2006/main">
-            <a:pPr algn="l"/>
-            <a:r>
-              <a:rPr lang="en-US" sz="1500" b="0">
-                <a:solidFill>
-                  <a:srgbClr val="0F172A"/>
-                </a:solidFill>
-                <a:latin typeface="Consolas"/>
-                <a:ea typeface="Consolas"/>
-              </a:rPr>
-              <a:t>• updated_by: VARCHAR(50)</a:t>
-            </a:r>
-          </a:p>
-        </p:txBody>
-      </p:sp>
+          <a:xfrm>
+            <a:off x="548640" y="868680"/>
+            <a:ext cx="11064240" cy="320040"/>
+          </a:xfrm>
+          <a:prstGeom prst="rect">
+            <a:avLst/>
+          </a:prstGeom>
+          <a:noFill/>
+        </p:spPr>
+        <p:txBody>
+          <a:bodyPr wrap="none">
+            <a:spAutoFit/>
+          </a:bodyPr>
+          <a:lstStyle/>
+          <a:p>
+            <a:pPr>
+              <a:defRPr sz="1300">
+                <a:solidFill>
+                  <a:srgbClr val="38BDF8"/>
+                </a:solidFill>
+                <a:latin typeface="Calibri"/>
+              </a:defRPr>
+            </a:pPr>
+            <a:r>
+              <a:t>Mô hình quan hệ thực thể toàn diện chuẩn PostgreSQL: Khóa chính (PK), Khóa ngoại (FK) &amp; Luồng tích hợp</a:t>
+            </a:r>
+          </a:p>
+        </p:txBody>
+      </p:sp>
+      <p:pic xmlns:a="http://schemas.openxmlformats.org/drawingml/2006/main" xmlns:r="http://schemas.openxmlformats.org/officeDocument/2006/relationships">
+        <p:nvPicPr>
+          <p:cNvPr id="4" name="Picture 3" descr="database_erd_diagram.png"/>
+          <p:cNvPicPr>
+            <a:picLocks noChangeAspect="1"/>
+          </p:cNvPicPr>
+          <p:nvPr/>
+        </p:nvPicPr>
+        <p:blipFill>
+          <a:blip r:embed="rId3"/>
+          <a:stretch>
+            <a:fillRect/>
+          </a:stretch>
+        </p:blipFill>
+        <p:spPr>
+          <a:xfrm>
+            <a:off x="548640" y="1234440"/>
+            <a:ext cx="11091672" cy="5257800"/>
+          </a:xfrm>
+          <a:prstGeom prst="rect">
+            <a:avLst/>
+          </a:prstGeom>
+        </p:spPr>
+      </p:pic>
     </p:spTree>
   </p:cSld>
 </p:sld>

</xml_diff>